<commit_message>
Portada: nombre completo del autor y escalera de precios con las cinco marcas
Los logos se cargan de assets/logos/ en monocromo cuando están los cinco;
de momento hay H&M y Zara (Simple Icons, CC0) y la portada usa los nombres.

Co-Authored-By: Claude Opus 5.5 <noreply@anthropic.com>
Claude-Session: https://claude.ai/code/session_01C3M1KU5UsGHqGWm1X55cnH
</commit_message>
<xml_diff>
--- a/output/posicionamiento_precio_moda.pptx
+++ b/output/posicionamiento_precio_moda.pptx
@@ -4301,17 +4301,17 @@
         </p:nvSpPr>
         <p:spPr>
           <a:xfrm>
-            <a:off x="731520" y="1828800"/>
-            <a:ext cx="7680960" cy="2011680"/>
+            <a:off x="731520" y="1371600"/>
+            <a:ext cx="5577840" cy="2651760"/>
           </a:xfrm>
         </p:spPr>
         <p:txBody>
-          <a:bodyPr wrap="square" anchor="b"/>
+          <a:bodyPr wrap="square" anchor="b" lIns="0" rIns="0"/>
           <a:lstStyle/>
           <a:p>
             <a:pPr algn="l"/>
             <a:r>
-              <a:rPr sz="4000" b="1" i="0">
+              <a:rPr sz="3800" b="1" i="0">
                 <a:solidFill>
                   <a:srgbClr val="333333"/>
                 </a:solidFill>
@@ -4334,12 +4334,12 @@
         </p:nvSpPr>
         <p:spPr>
           <a:xfrm>
-            <a:off x="731520" y="4023360"/>
-            <a:ext cx="7680960" cy="914400"/>
+            <a:off x="731520" y="4206240"/>
+            <a:ext cx="5577840" cy="914400"/>
           </a:xfrm>
         </p:spPr>
         <p:txBody>
-          <a:bodyPr wrap="square"/>
+          <a:bodyPr wrap="square" lIns="0" rIns="0"/>
           <a:lstStyle/>
           <a:p>
             <a:pPr algn="l"/>
@@ -4350,7 +4350,7 @@
                 </a:solidFill>
                 <a:latin typeface="Calibri"/>
               </a:rPr>
-              <a:t>Posicionamiento de precio de Primark, Lefties, H&amp;M, Zara y Massimo Dutti a partir de su catálogo online</a:t>
+              <a:t>Posicionamiento de precio de cinco cadenas a partir de su catálogo online</a:t>
             </a:r>
           </a:p>
         </p:txBody>
@@ -4363,8 +4363,8 @@
         </p:nvSpPr>
         <p:spPr>
           <a:xfrm>
-            <a:off x="731520" y="5760720"/>
-            <a:ext cx="7315200" cy="365760"/>
+            <a:off x="731520" y="5532120"/>
+            <a:ext cx="5577840" cy="731520"/>
           </a:xfrm>
           <a:prstGeom prst="rect">
             <a:avLst/>
@@ -4377,6 +4377,22 @@
           </a:bodyPr>
           <a:lstStyle/>
           <a:p>
+            <a:pPr algn="l">
+              <a:spcAft>
+                <a:spcPts val="800"/>
+              </a:spcAft>
+            </a:pPr>
+            <a:r>
+              <a:rPr sz="1400" b="1" i="0">
+                <a:solidFill>
+                  <a:srgbClr val="333333"/>
+                </a:solidFill>
+                <a:latin typeface="Calibri"/>
+              </a:rPr>
+              <a:t>Javier Benítez Escobedo</a:t>
+            </a:r>
+          </a:p>
+          <a:p>
             <a:pPr algn="l"/>
             <a:r>
               <a:rPr sz="1400" b="0" i="0">
@@ -4385,7 +4401,7 @@
                 </a:solidFill>
                 <a:latin typeface="Calibri"/>
               </a:rPr>
-              <a:t>Javi  ·  Datos recogidos el 10/10/2026</a:t>
+              <a:t>Datos recogidos el 10/10/2026</a:t>
             </a:r>
           </a:p>
         </p:txBody>
@@ -4398,8 +4414,108 @@
         </p:nvSpPr>
         <p:spPr>
           <a:xfrm>
-            <a:off x="9052560" y="4206240"/>
-            <a:ext cx="640080" cy="914400"/>
+            <a:off x="6613855" y="4973489"/>
+            <a:ext cx="932688" cy="1015830"/>
+          </a:xfrm>
+          <a:prstGeom prst="rect">
+            <a:avLst/>
+          </a:prstGeom>
+          <a:solidFill>
+            <a:srgbClr val="D3D3D3"/>
+          </a:solidFill>
+          <a:ln>
+            <a:noFill/>
+          </a:ln>
+          <a:effectLst/>
+        </p:spPr>
+        <p:txBody>
+          <a:bodyPr rtlCol="0" anchor="ctr"/>
+          <a:lstStyle/>
+          <a:p>
+            <a:pPr algn="ctr"/>
+          </a:p>
+        </p:txBody>
+      </p:sp>
+      <p:sp>
+        <p:nvSpPr>
+          <p:cNvPr id="6" name="TextBox 5"/>
+          <p:cNvSpPr txBox="1"/>
+          <p:nvPr/>
+        </p:nvSpPr>
+        <p:spPr>
+          <a:xfrm>
+            <a:off x="6613855" y="5046641"/>
+            <a:ext cx="932688" cy="274320"/>
+          </a:xfrm>
+          <a:prstGeom prst="rect">
+            <a:avLst/>
+          </a:prstGeom>
+          <a:noFill/>
+        </p:spPr>
+        <p:txBody>
+          <a:bodyPr wrap="square" anchor="t" lIns="0" rIns="0" tIns="0" bIns="0">
+            <a:spAutoFit/>
+          </a:bodyPr>
+          <a:lstStyle/>
+          <a:p>
+            <a:pPr algn="ctr"/>
+            <a:r>
+              <a:rPr sz="1100" b="1" i="0">
+                <a:solidFill>
+                  <a:srgbClr val="333333"/>
+                </a:solidFill>
+                <a:latin typeface="Calibri"/>
+              </a:rPr>
+              <a:t>18,00 €</a:t>
+            </a:r>
+          </a:p>
+        </p:txBody>
+      </p:sp>
+      <p:sp>
+        <p:nvSpPr>
+          <p:cNvPr id="7" name="TextBox 6"/>
+          <p:cNvSpPr txBox="1"/>
+          <p:nvPr/>
+        </p:nvSpPr>
+        <p:spPr>
+          <a:xfrm>
+            <a:off x="6568135" y="4635161"/>
+            <a:ext cx="1024128" cy="246888"/>
+          </a:xfrm>
+          <a:prstGeom prst="rect">
+            <a:avLst/>
+          </a:prstGeom>
+          <a:noFill/>
+        </p:spPr>
+        <p:txBody>
+          <a:bodyPr wrap="square" anchor="b" lIns="0" rIns="0" tIns="0" bIns="0">
+            <a:spAutoFit/>
+          </a:bodyPr>
+          <a:lstStyle/>
+          <a:p>
+            <a:pPr algn="ctr"/>
+            <a:r>
+              <a:rPr sz="1300" b="1" i="0">
+                <a:solidFill>
+                  <a:srgbClr val="333333"/>
+                </a:solidFill>
+                <a:latin typeface="Calibri"/>
+              </a:rPr>
+              <a:t>Primark</a:t>
+            </a:r>
+          </a:p>
+        </p:txBody>
+      </p:sp>
+      <p:sp>
+        <p:nvSpPr>
+          <p:cNvPr id="8" name="Rectangle 7"/>
+          <p:cNvSpPr/>
+          <p:nvPr/>
+        </p:nvSpPr>
+        <p:spPr>
+          <a:xfrm>
+            <a:off x="7637983" y="4861183"/>
+            <a:ext cx="932688" cy="1128136"/>
           </a:xfrm>
           <a:prstGeom prst="rect">
             <a:avLst/>
@@ -4422,14 +4538,184 @@
       </p:sp>
       <p:sp>
         <p:nvSpPr>
-          <p:cNvPr id="6" name="Rectangle 5"/>
+          <p:cNvPr id="9" name="TextBox 8"/>
+          <p:cNvSpPr txBox="1"/>
+          <p:nvPr/>
+        </p:nvSpPr>
+        <p:spPr>
+          <a:xfrm>
+            <a:off x="7637983" y="4934335"/>
+            <a:ext cx="932688" cy="274320"/>
+          </a:xfrm>
+          <a:prstGeom prst="rect">
+            <a:avLst/>
+          </a:prstGeom>
+          <a:noFill/>
+        </p:spPr>
+        <p:txBody>
+          <a:bodyPr wrap="square" anchor="t" lIns="0" rIns="0" tIns="0" bIns="0">
+            <a:spAutoFit/>
+          </a:bodyPr>
+          <a:lstStyle/>
+          <a:p>
+            <a:pPr algn="ctr"/>
+            <a:r>
+              <a:rPr sz="1100" b="1" i="0">
+                <a:solidFill>
+                  <a:srgbClr val="FFFFFF"/>
+                </a:solidFill>
+                <a:latin typeface="Calibri"/>
+              </a:rPr>
+              <a:t>19,99 €</a:t>
+            </a:r>
+          </a:p>
+        </p:txBody>
+      </p:sp>
+      <p:sp>
+        <p:nvSpPr>
+          <p:cNvPr id="10" name="TextBox 9"/>
+          <p:cNvSpPr txBox="1"/>
+          <p:nvPr/>
+        </p:nvSpPr>
+        <p:spPr>
+          <a:xfrm>
+            <a:off x="7592263" y="4522855"/>
+            <a:ext cx="1024128" cy="246888"/>
+          </a:xfrm>
+          <a:prstGeom prst="rect">
+            <a:avLst/>
+          </a:prstGeom>
+          <a:noFill/>
+        </p:spPr>
+        <p:txBody>
+          <a:bodyPr wrap="square" anchor="b" lIns="0" rIns="0" tIns="0" bIns="0">
+            <a:spAutoFit/>
+          </a:bodyPr>
+          <a:lstStyle/>
+          <a:p>
+            <a:pPr algn="ctr"/>
+            <a:r>
+              <a:rPr sz="1300" b="1" i="0">
+                <a:solidFill>
+                  <a:srgbClr val="2A64A8"/>
+                </a:solidFill>
+                <a:latin typeface="Calibri"/>
+              </a:rPr>
+              <a:t>Lefties</a:t>
+            </a:r>
+          </a:p>
+        </p:txBody>
+      </p:sp>
+      <p:sp>
+        <p:nvSpPr>
+          <p:cNvPr id="11" name="Rectangle 10"/>
           <p:cNvSpPr/>
           <p:nvPr/>
         </p:nvSpPr>
         <p:spPr>
           <a:xfrm>
-            <a:off x="9829800" y="3291839"/>
-            <a:ext cx="640080" cy="1828800"/>
+            <a:off x="8662111" y="4014658"/>
+            <a:ext cx="932688" cy="1974661"/>
+          </a:xfrm>
+          <a:prstGeom prst="rect">
+            <a:avLst/>
+          </a:prstGeom>
+          <a:solidFill>
+            <a:srgbClr val="D3D3D3"/>
+          </a:solidFill>
+          <a:ln>
+            <a:noFill/>
+          </a:ln>
+          <a:effectLst/>
+        </p:spPr>
+        <p:txBody>
+          <a:bodyPr rtlCol="0" anchor="ctr"/>
+          <a:lstStyle/>
+          <a:p>
+            <a:pPr algn="ctr"/>
+          </a:p>
+        </p:txBody>
+      </p:sp>
+      <p:sp>
+        <p:nvSpPr>
+          <p:cNvPr id="12" name="TextBox 11"/>
+          <p:cNvSpPr txBox="1"/>
+          <p:nvPr/>
+        </p:nvSpPr>
+        <p:spPr>
+          <a:xfrm>
+            <a:off x="8662111" y="4087810"/>
+            <a:ext cx="932688" cy="274320"/>
+          </a:xfrm>
+          <a:prstGeom prst="rect">
+            <a:avLst/>
+          </a:prstGeom>
+          <a:noFill/>
+        </p:spPr>
+        <p:txBody>
+          <a:bodyPr wrap="square" anchor="t" lIns="0" rIns="0" tIns="0" bIns="0">
+            <a:spAutoFit/>
+          </a:bodyPr>
+          <a:lstStyle/>
+          <a:p>
+            <a:pPr algn="ctr"/>
+            <a:r>
+              <a:rPr sz="1100" b="1" i="0">
+                <a:solidFill>
+                  <a:srgbClr val="333333"/>
+                </a:solidFill>
+                <a:latin typeface="Calibri"/>
+              </a:rPr>
+              <a:t>34,99 €</a:t>
+            </a:r>
+          </a:p>
+        </p:txBody>
+      </p:sp>
+      <p:sp>
+        <p:nvSpPr>
+          <p:cNvPr id="13" name="TextBox 12"/>
+          <p:cNvSpPr txBox="1"/>
+          <p:nvPr/>
+        </p:nvSpPr>
+        <p:spPr>
+          <a:xfrm>
+            <a:off x="8616391" y="3676330"/>
+            <a:ext cx="1024128" cy="246888"/>
+          </a:xfrm>
+          <a:prstGeom prst="rect">
+            <a:avLst/>
+          </a:prstGeom>
+          <a:noFill/>
+        </p:spPr>
+        <p:txBody>
+          <a:bodyPr wrap="square" anchor="b" lIns="0" rIns="0" tIns="0" bIns="0">
+            <a:spAutoFit/>
+          </a:bodyPr>
+          <a:lstStyle/>
+          <a:p>
+            <a:pPr algn="ctr"/>
+            <a:r>
+              <a:rPr sz="1300" b="1" i="0">
+                <a:solidFill>
+                  <a:srgbClr val="333333"/>
+                </a:solidFill>
+                <a:latin typeface="Calibri"/>
+              </a:rPr>
+              <a:t>H&amp;M</a:t>
+            </a:r>
+          </a:p>
+        </p:txBody>
+      </p:sp>
+      <p:sp>
+        <p:nvSpPr>
+          <p:cNvPr id="14" name="Rectangle 13"/>
+          <p:cNvSpPr/>
+          <p:nvPr/>
+        </p:nvSpPr>
+        <p:spPr>
+          <a:xfrm>
+            <a:off x="9686239" y="3960480"/>
+            <a:ext cx="932688" cy="2028839"/>
           </a:xfrm>
           <a:prstGeom prst="rect">
             <a:avLst/>
@@ -4452,14 +4738,84 @@
       </p:sp>
       <p:sp>
         <p:nvSpPr>
-          <p:cNvPr id="7" name="Rectangle 6"/>
+          <p:cNvPr id="15" name="TextBox 14"/>
+          <p:cNvSpPr txBox="1"/>
+          <p:nvPr/>
+        </p:nvSpPr>
+        <p:spPr>
+          <a:xfrm>
+            <a:off x="9686239" y="4033632"/>
+            <a:ext cx="932688" cy="274320"/>
+          </a:xfrm>
+          <a:prstGeom prst="rect">
+            <a:avLst/>
+          </a:prstGeom>
+          <a:noFill/>
+        </p:spPr>
+        <p:txBody>
+          <a:bodyPr wrap="square" anchor="t" lIns="0" rIns="0" tIns="0" bIns="0">
+            <a:spAutoFit/>
+          </a:bodyPr>
+          <a:lstStyle/>
+          <a:p>
+            <a:pPr algn="ctr"/>
+            <a:r>
+              <a:rPr sz="1100" b="1" i="0">
+                <a:solidFill>
+                  <a:srgbClr val="FFFFFF"/>
+                </a:solidFill>
+                <a:latin typeface="Calibri"/>
+              </a:rPr>
+              <a:t>35,95 €</a:t>
+            </a:r>
+          </a:p>
+        </p:txBody>
+      </p:sp>
+      <p:sp>
+        <p:nvSpPr>
+          <p:cNvPr id="16" name="TextBox 15"/>
+          <p:cNvSpPr txBox="1"/>
+          <p:nvPr/>
+        </p:nvSpPr>
+        <p:spPr>
+          <a:xfrm>
+            <a:off x="9640519" y="3622152"/>
+            <a:ext cx="1024128" cy="246888"/>
+          </a:xfrm>
+          <a:prstGeom prst="rect">
+            <a:avLst/>
+          </a:prstGeom>
+          <a:noFill/>
+        </p:spPr>
+        <p:txBody>
+          <a:bodyPr wrap="square" anchor="b" lIns="0" rIns="0" tIns="0" bIns="0">
+            <a:spAutoFit/>
+          </a:bodyPr>
+          <a:lstStyle/>
+          <a:p>
+            <a:pPr algn="ctr"/>
+            <a:r>
+              <a:rPr sz="1300" b="1" i="0">
+                <a:solidFill>
+                  <a:srgbClr val="2A64A8"/>
+                </a:solidFill>
+                <a:latin typeface="Calibri"/>
+              </a:rPr>
+              <a:t>Zara</a:t>
+            </a:r>
+          </a:p>
+        </p:txBody>
+      </p:sp>
+      <p:sp>
+        <p:nvSpPr>
+          <p:cNvPr id="17" name="Rectangle 16"/>
           <p:cNvSpPr/>
           <p:nvPr/>
         </p:nvSpPr>
         <p:spPr>
           <a:xfrm>
-            <a:off x="10607040" y="2377439"/>
-            <a:ext cx="640080" cy="2743200"/>
+            <a:off x="10710367" y="2606039"/>
+            <a:ext cx="932688" cy="3383280"/>
           </a:xfrm>
           <a:prstGeom prst="rect">
             <a:avLst/>
@@ -4477,6 +4833,127 @@
           <a:lstStyle/>
           <a:p>
             <a:pPr algn="ctr"/>
+          </a:p>
+        </p:txBody>
+      </p:sp>
+      <p:sp>
+        <p:nvSpPr>
+          <p:cNvPr id="18" name="TextBox 17"/>
+          <p:cNvSpPr txBox="1"/>
+          <p:nvPr/>
+        </p:nvSpPr>
+        <p:spPr>
+          <a:xfrm>
+            <a:off x="10710367" y="2679191"/>
+            <a:ext cx="932688" cy="274320"/>
+          </a:xfrm>
+          <a:prstGeom prst="rect">
+            <a:avLst/>
+          </a:prstGeom>
+          <a:noFill/>
+        </p:spPr>
+        <p:txBody>
+          <a:bodyPr wrap="square" anchor="t" lIns="0" rIns="0" tIns="0" bIns="0">
+            <a:spAutoFit/>
+          </a:bodyPr>
+          <a:lstStyle/>
+          <a:p>
+            <a:pPr algn="ctr"/>
+            <a:r>
+              <a:rPr sz="1100" b="1" i="0">
+                <a:solidFill>
+                  <a:srgbClr val="FFFFFF"/>
+                </a:solidFill>
+                <a:latin typeface="Calibri"/>
+              </a:rPr>
+              <a:t>59,95 €</a:t>
+            </a:r>
+          </a:p>
+        </p:txBody>
+      </p:sp>
+      <p:sp>
+        <p:nvSpPr>
+          <p:cNvPr id="19" name="TextBox 18"/>
+          <p:cNvSpPr txBox="1"/>
+          <p:nvPr/>
+        </p:nvSpPr>
+        <p:spPr>
+          <a:xfrm>
+            <a:off x="10664647" y="2020823"/>
+            <a:ext cx="1024128" cy="493776"/>
+          </a:xfrm>
+          <a:prstGeom prst="rect">
+            <a:avLst/>
+          </a:prstGeom>
+          <a:noFill/>
+        </p:spPr>
+        <p:txBody>
+          <a:bodyPr wrap="square" anchor="b" lIns="0" rIns="0" tIns="0" bIns="0">
+            <a:spAutoFit/>
+          </a:bodyPr>
+          <a:lstStyle/>
+          <a:p>
+            <a:pPr algn="ctr">
+              <a:spcAft>
+                <a:spcPts val="0"/>
+              </a:spcAft>
+            </a:pPr>
+            <a:r>
+              <a:rPr sz="1300" b="1" i="0">
+                <a:solidFill>
+                  <a:srgbClr val="2A64A8"/>
+                </a:solidFill>
+                <a:latin typeface="Calibri"/>
+              </a:rPr>
+              <a:t>Massimo</a:t>
+            </a:r>
+          </a:p>
+          <a:p>
+            <a:pPr algn="ctr"/>
+            <a:r>
+              <a:rPr sz="1300" b="1" i="0">
+                <a:solidFill>
+                  <a:srgbClr val="2A64A8"/>
+                </a:solidFill>
+                <a:latin typeface="Calibri"/>
+              </a:rPr>
+              <a:t>Dutti</a:t>
+            </a:r>
+          </a:p>
+        </p:txBody>
+      </p:sp>
+      <p:sp>
+        <p:nvSpPr>
+          <p:cNvPr id="20" name="TextBox 19"/>
+          <p:cNvSpPr txBox="1"/>
+          <p:nvPr/>
+        </p:nvSpPr>
+        <p:spPr>
+          <a:xfrm>
+            <a:off x="6613855" y="6080759"/>
+            <a:ext cx="5029200" cy="274320"/>
+          </a:xfrm>
+          <a:prstGeom prst="rect">
+            <a:avLst/>
+          </a:prstGeom>
+          <a:noFill/>
+        </p:spPr>
+        <p:txBody>
+          <a:bodyPr wrap="square" anchor="t" lIns="0" rIns="0" tIns="0" bIns="0">
+            <a:spAutoFit/>
+          </a:bodyPr>
+          <a:lstStyle/>
+          <a:p>
+            <a:pPr algn="r"/>
+            <a:r>
+              <a:rPr sz="1000" b="0" i="0">
+                <a:solidFill>
+                  <a:srgbClr val="6B6B6B"/>
+                </a:solidFill>
+                <a:latin typeface="Calibri"/>
+              </a:rPr>
+              <a:t>Altura de cada peldaño: precio mediano del vaquero básico. En azul, Inditex.</a:t>
+            </a:r>
           </a:p>
         </p:txBody>
       </p:sp>

</xml_diff>